<commit_message>
TL03 Sim-Review: 8 VP + 7 VP-T eingearbeitet + sim_review true
Teilnehmer-Sim + Trainer-Trainability: Flipchart-Anker, 1-3-1 als Merkkarte,
AB-2-Vorbereitung, Teamphasenuhr-Pflichtgrafik, L3-Termin, Herzberg-Methodik,
Einwand 5 (Kontrollbeduerfnis) + 6 (Komplexitaet), Cheat-Sheet Sec 3.5,
Schreibphasen-Rahmung, AB-2-Planungsraster, Adjourning-Regel, L3-Terminblatt,
Feedback-Aussage 7. Workbook/Trainerhandbuch/Deck neu, Validator 0/0.

Co-Authored-By: Claude Opus 4.8 <noreply@anthropic.com>
</commit_message>
<xml_diff>
--- a/protected-downloads/praesentation/TL03.pptx
+++ b/protected-downloads/praesentation/TL03.pptx
@@ -12065,7 +12065,7 @@
                 </a:solidFill>
                 <a:latin typeface="Arial"/>
               </a:rPr>
-              <a:t>  ·  Lehrgespräch mit Visualisierung: Delegation vs. Aufgabenabgabe; die vier Delegationsgrade (Tabelle Sec 4); Reifegrad-Delegationsgrad-Matrix (Verbindung zu TL02); Monkey-Management-Prinzip (Oncken &amp; Wass, 1974 ). Trainer stellt eine gezielte Frage in die Runde: „Welchen Delegationsgrad nutzen Sie am häufigsten – und warum?" Kurze Reaktion sammeln, nicht vertiefen.</a:t>
+              <a:t>  ·  Lehrgespräch mit Visualisierung: Delegation vs. Aufgabenabgabe; die vier Delegationsgrade (Tabelle Sec 4); Reifegrad-Delegationsgrad-Matrix (Verbindung zu TL02); Monkey-Management-Prinzip (Oncken &amp; Wass, 1974 ). Trainer stellt eine gezielte Frage in die Runde: „Welchen Delegationsgrad nutzen Sie am häufigsten – und warum?" Kurze Reaktion sammeln, nicht vertiefen. Flipchart-Anker einlösen: „Welche Ihrer Nennungen vom Anfang spiegelt sich in den Delegationsgraden wider?"</a:t>
             </a:r>
           </a:p>
           <a:p>
@@ -12176,7 +12176,7 @@
                 </a:solidFill>
                 <a:latin typeface="Arial"/>
               </a:rPr>
-              <a:t>  ·  Trainer präsentiert den Praxisfall kurz (max. 5 Min. mündlich, TN lesen Sec 4 parallel mit). Aufgaben 1–4 des Praxisfalls werden als moderierte Plenumsdiskussion bearbeitet: TN arbeiten still 8 Minuten (Aufgaben 1 und 2), dann Plenum: Phasenzuordnung Sabines Team (Storming-Argumentation), SDT-Analyse Thomas F. und Julia S. Aufgaben 3 und 4 werden als Überleitung zur kollegialen Fallberatung genutzt – nicht vollständig ausdiskutiert, sondern als Fragen geöffnet, auf die die Teilnehmer im nächsten Block eigene Situationen einbringen.</a:t>
+              <a:t>  ·  Trainer präsentiert den Praxisfall kurz (max. 5 Min. mündlich, TN lesen Sec 4 parallel mit). Aufgaben 1–4 des Praxisfalls werden als moderierte Plenumsdiskussion bearbeitet: TN arbeiten still 8 Minuten (Aufgaben 1 und 2), dann Plenum: Phasenzuordnung Sabines Team (Storming-Argumentation), SDT-Analyse Thomas F. und Julia S. Aufgaben 3 und 4 werden als Überleitung zur kollegialen Fallberatung genutzt – nicht vollständig ausdiskutiert, sondern als Fragen geöffnet, auf die die Teilnehmer im nächsten Block eigene Situationen einbringen. Flipchart-Anker einlösen: „Wer von Ihnen hat am Anfang eine Situation genannt, die sich jetzt in Sabine K. wiederfindet?"</a:t>
             </a:r>
           </a:p>
           <a:p>
@@ -12213,7 +12213,7 @@
                 </a:solidFill>
                 <a:latin typeface="Arial"/>
               </a:rPr>
-              <a:t>  ·  Jeder TN wählt still eine konkrete Führungssituation aus dem eigenen Alltag (ca. 5 Minuten): Entweder eine Situation, in der Delegation nicht funktioniert hat (Rückdelegation, falscher Grad, fehlendes Gespräch) – oder eine Mitarbeitende/r, bei dem die Motivation unklar ist. Format: 3–4 TN stellen ihren Fall in je 60 Sekunden vor. Das Plenum beantwortet kollegial: Welcher Delegationsgrad wäre angemessen gewesen? Welches SDT-Grundbedürfnis steht hinter dem Muster? Welche Führungshandlung ist als nächstes sinnvoll? Trainer moderiert den Abgleich zwischen Einschätzungen, kein Rollenspiel, keine Verhaltens-Simulation – Analyse und Gesprächsvorbereitung auf Papier. AB-2 wird in diesem Block vorbereitet (Delegationsgespräch strukturieren).</a:t>
+              <a:t>  ·  Jeder TN wählt still eine konkrete Führungssituation aus dem eigenen Alltag (ca. 5 Minuten): Entweder eine Situation, in der Delegation nicht funktioniert hat (Rückdelegation, falscher Grad, fehlendes Gespräch) – oder eine Mitarbeitende/r, bei dem die Motivation unklar ist. Wichtig: Alle TN notieren in dieser stillen Phase zugleich, welche Situation sie für AB-2 nutzen wollen – so hat auch, wer keinen eigenen Fall vorstellt, eine Situation für die Formulierungswerkstatt bereit. Format: 3–4 TN stellen ihren Fall in je 60 Sekunden vor. Das Plenum beantwortet kollegial: Welcher Delegationsgrad wäre angemessen gewesen? Welches SDT-Grundbedürfnis steht hinter dem Muster? Welche Führungshandlung ist als nächstes sinnvoll? Trainer moderiert den Abgleich zwischen Einschätzungen, kein Rollenspiel, keine Verhaltens-Simulation – Analyse und Gesprächsvorbereitung auf Papier. AB-2 wird in diesem Block vorbereitet (Delegationsgespräch strukturieren).</a:t>
             </a:r>
           </a:p>
           <a:p>
@@ -12398,7 +12398,7 @@
                 </a:solidFill>
                 <a:latin typeface="Arial"/>
               </a:rPr>
-              <a:t>  ·  Trainer stellt die drei Transferaufgaben (Sec 5) vor. TN formulieren still ihren konkreten ersten Schritt für die nächste Woche (Delegation oder Teamphasen-Beobachtung). Feedbackbogen (Sec 6.1) ausfüllen (ca. 5 Min.). Wissenstest (Sec 6.2) als optionale Hausaufgabe ausgeben. Trainer schließt mit dem Prüfsatz aus Reflexionsfrage 4: „Stellen Sie sich vor, einer Ihrer Mitarbeitenden beschreibt in drei Monaten, wie sich Ihre Führung verändert hat – was soll er sagen?" Folgetermin Beobachtungsgespräch / L3-Mechanismus ansprechen.</a:t>
+              <a:t>  ·  Trainer stellt die drei Transferaufgaben (Sec 5) vor. TN formulieren still ihren konkreten ersten Schritt für die nächste Woche (Delegation oder Teamphasen-Beobachtung). Feedbackbogen (Sec 6.1) ausfüllen (ca. 5 Min.). Wissenstest (Sec 6.2) als optionale Hausaufgabe ausgeben. Trainer schließt mit dem Prüfsatz aus Reflexionsfrage 4: „Stellen Sie sich vor, einer Ihrer Mitarbeitenden beschreibt in drei Monaten, wie sich Ihre Führung verändert hat – was soll er sagen?" L3-Mechanismus: TN tragen den Termin für das Beobachtungsgespräch (4–8 Wochen, ca. 30 Min. mit Bereichsleitung) noch im Workshop in ihren Kalender ein (Terminierungsblatt Sec 6.3). Für TN ohne festes Einzelgespräch-Format: das Einstiegsformat ist einfach – 20 Minuten, kein Thema außer „Wie geht es Ihnen?".</a:t>
             </a:r>
           </a:p>
         </p:txBody>

</xml_diff>